<commit_message>
update the numbers in the first and second presentations
</commit_message>
<xml_diff>
--- a/cpu/docs/presentations/output/PIC_Bunea_Cosmin-Andrei.pptx
+++ b/cpu/docs/presentations/output/PIC_Bunea_Cosmin-Andrei.pptx
@@ -2,19 +2,19 @@
 <file path=ppt/presentation.xml><?xml version="1.0" encoding="utf-8"?>
 <p:presentation xmlns:p="http://schemas.openxmlformats.org/presentationml/2006/main">
   <p:sldMasterIdLst>
-    <p:sldMasterId xmlns:r="http://schemas.openxmlformats.org/officeDocument/2006/relationships" id="2147483648" r:id="R792e57d82b0a471f"/>
+    <p:sldMasterId xmlns:r="http://schemas.openxmlformats.org/officeDocument/2006/relationships" id="2147483648" r:id="R00199a562e264d81"/>
   </p:sldMasterIdLst>
   <p:notesMasterIdLst>
-    <p:notesMasterId xmlns:r="http://schemas.openxmlformats.org/officeDocument/2006/relationships" r:id="R40ba5c9781c24b0a"/>
+    <p:notesMasterId xmlns:r="http://schemas.openxmlformats.org/officeDocument/2006/relationships" r:id="Rb756b72e3d494f8f"/>
   </p:notesMasterIdLst>
   <p:sldIdLst>
-    <p:sldId xmlns:r="http://schemas.openxmlformats.org/officeDocument/2006/relationships" id="256" r:id="R55e021a74dbe4f42"/>
-    <p:sldId xmlns:r="http://schemas.openxmlformats.org/officeDocument/2006/relationships" id="257" r:id="R3d1beb96cfc24fe7"/>
-    <p:sldId xmlns:r="http://schemas.openxmlformats.org/officeDocument/2006/relationships" id="258" r:id="Ra64672e7bfa2479f"/>
-    <p:sldId xmlns:r="http://schemas.openxmlformats.org/officeDocument/2006/relationships" id="259" r:id="R96fc8738e4be490a"/>
-    <p:sldId xmlns:r="http://schemas.openxmlformats.org/officeDocument/2006/relationships" id="260" r:id="R08e5fd40eea746fe"/>
-    <p:sldId xmlns:r="http://schemas.openxmlformats.org/officeDocument/2006/relationships" id="261" r:id="Rd3abd99ce71c42e7"/>
-    <p:sldId xmlns:r="http://schemas.openxmlformats.org/officeDocument/2006/relationships" id="262" r:id="R4c304f3c67b44c27"/>
+    <p:sldId xmlns:r="http://schemas.openxmlformats.org/officeDocument/2006/relationships" id="256" r:id="R8cc4b67e66dc497d"/>
+    <p:sldId xmlns:r="http://schemas.openxmlformats.org/officeDocument/2006/relationships" id="257" r:id="Rd32fc8646d354205"/>
+    <p:sldId xmlns:r="http://schemas.openxmlformats.org/officeDocument/2006/relationships" id="258" r:id="Rbb222943c1ec4cd9"/>
+    <p:sldId xmlns:r="http://schemas.openxmlformats.org/officeDocument/2006/relationships" id="259" r:id="Ra9fa8637e8b842ec"/>
+    <p:sldId xmlns:r="http://schemas.openxmlformats.org/officeDocument/2006/relationships" id="260" r:id="Rc6e5614d0aa54f27"/>
+    <p:sldId xmlns:r="http://schemas.openxmlformats.org/officeDocument/2006/relationships" id="261" r:id="R50791612d98140a0"/>
+    <p:sldId xmlns:r="http://schemas.openxmlformats.org/officeDocument/2006/relationships" id="262" r:id="R47a667478f4b464c"/>
   </p:sldIdLst>
   <p:sldSz cx="18288000" cy="10287000"/>
   <p:notesSz cx="6858000" cy="9144000"/>
@@ -777,7 +777,7 @@
           <a:lstStyle xmlns:a="http://schemas.openxmlformats.org/drawingml/2006/main"/>
           <a:p xmlns:a="http://schemas.openxmlformats.org/drawingml/2006/main">
             <a:r>
-              <a:t>1:40. Follow the independent reference into the stimulus and the checks. The Python model computes the winner for 24 orderings of the bands, together with masks and ties. The directed tests add the temporal part: claim, EOI, a coincident edge, the stack limit, deadlines and reset. AXI is checked separately; the PULP comparison covers the decoder and a register profile with 96 WSTRB / AW-W / backpressure combinations, plus error and reset cases. It is not a proof of equivalence with the whole PULP library.</a:t>
+              <a:t>1:40. Follow the independent reference into the stimulus and the checks. The Python model computes the winner for 24 orderings of the bands, together with masks and ties. The directed tests add the temporal part: claim, EOI, a coincident edge, the stack limit, deadlines and reset. AXI is checked separately; the PULP comparison covers the decoder and a register profile with 96 WSTRB / AW-W / backpressure combinations, plus error and reset cases.</a:t>
             </a:r>
           </a:p>
         </p:txBody>
@@ -985,7 +985,7 @@
   </p:cSld>
   <p:clrMap bg1="lt1" tx1="dk1" bg2="lt2" tx2="dk2" accent1="accent1" accent2="accent2" accent3="accent3" accent4="accent4" accent5="accent5" accent6="accent6" hlink="hlink" folHlink="folHlink"/>
   <p:sldLayoutIdLst>
-    <p:sldLayoutId xmlns:r="http://schemas.openxmlformats.org/officeDocument/2006/relationships" id="2147483649" r:id="Rdcf4f574b3854ced"/>
+    <p:sldLayoutId xmlns:r="http://schemas.openxmlformats.org/officeDocument/2006/relationships" id="2147483649" r:id="R25bf6eeb2df64839"/>
   </p:sldLayoutIdLst>
   <p:txStyles>
     <p:titleStyle>
@@ -1284,7 +1284,7 @@
           <p:cNvPr id="1" name="text">
             <a:extLst xmlns:a="http://schemas.openxmlformats.org/drawingml/2006/main">
               <a:ext uri="{FF2B5EF4-FFF2-40B4-BE49-F238E27FC236}">
-                <a16:creationId xmlns:a16="http://schemas.microsoft.com/office/drawing/2014/main" id="{337EEC2A-B987-4D3A-90BE-0CFA15F1F740}"/>
+                <a16:creationId xmlns:a16="http://schemas.microsoft.com/office/drawing/2014/main" id="{38098678-F287-45BD-A589-56ADA9729462}"/>
               </a:ext>
             </a:extLst>
           </p:cNvPr>
@@ -1329,7 +1329,7 @@
           <p:cNvPr id="2" name="">
             <a:extLst xmlns:a="http://schemas.openxmlformats.org/drawingml/2006/main">
               <a:ext uri="{FF2B5EF4-FFF2-40B4-BE49-F238E27FC236}">
-                <a16:creationId xmlns:a16="http://schemas.microsoft.com/office/drawing/2014/main" id="{F2D73FC5-B152-4C94-8822-1F6ABCE8D317}"/>
+                <a16:creationId xmlns:a16="http://schemas.microsoft.com/office/drawing/2014/main" id="{CE39DA55-E85D-4243-A258-5C645C0CE87E}"/>
               </a:ext>
             </a:extLst>
           </p:cNvPr>
@@ -1362,7 +1362,7 @@
           <p:cNvPr id="3" name="text">
             <a:extLst xmlns:a="http://schemas.openxmlformats.org/drawingml/2006/main">
               <a:ext uri="{FF2B5EF4-FFF2-40B4-BE49-F238E27FC236}">
-                <a16:creationId xmlns:a16="http://schemas.microsoft.com/office/drawing/2014/main" id="{3411838B-7CA9-401E-972A-8D399967BE10}"/>
+                <a16:creationId xmlns:a16="http://schemas.microsoft.com/office/drawing/2014/main" id="{5163D8F9-8CF2-437F-AA14-A7BCD846B1A7}"/>
               </a:ext>
             </a:extLst>
           </p:cNvPr>
@@ -1407,7 +1407,7 @@
           <p:cNvPr id="4" name="text">
             <a:extLst xmlns:a="http://schemas.openxmlformats.org/drawingml/2006/main">
               <a:ext uri="{FF2B5EF4-FFF2-40B4-BE49-F238E27FC236}">
-                <a16:creationId xmlns:a16="http://schemas.microsoft.com/office/drawing/2014/main" id="{C2D8E21E-CE6C-47CC-B9A4-5B1660D718E1}"/>
+                <a16:creationId xmlns:a16="http://schemas.microsoft.com/office/drawing/2014/main" id="{94564196-CBC6-4FF5-92C2-FB988D9CF174}"/>
               </a:ext>
             </a:extLst>
           </p:cNvPr>
@@ -1452,7 +1452,7 @@
           <p:cNvPr id="5" name="text">
             <a:extLst xmlns:a="http://schemas.openxmlformats.org/drawingml/2006/main">
               <a:ext uri="{FF2B5EF4-FFF2-40B4-BE49-F238E27FC236}">
-                <a16:creationId xmlns:a16="http://schemas.microsoft.com/office/drawing/2014/main" id="{6F87B202-3259-44EC-B71B-09060229A040}"/>
+                <a16:creationId xmlns:a16="http://schemas.microsoft.com/office/drawing/2014/main" id="{97A23A3B-9086-4060-96CB-2722710D5838}"/>
               </a:ext>
             </a:extLst>
           </p:cNvPr>
@@ -1497,7 +1497,7 @@
           <p:cNvPr id="6" name="text">
             <a:extLst xmlns:a="http://schemas.openxmlformats.org/drawingml/2006/main">
               <a:ext uri="{FF2B5EF4-FFF2-40B4-BE49-F238E27FC236}">
-                <a16:creationId xmlns:a16="http://schemas.microsoft.com/office/drawing/2014/main" id="{1265FD35-6258-4B53-8CD3-70BB8A7827F6}"/>
+                <a16:creationId xmlns:a16="http://schemas.microsoft.com/office/drawing/2014/main" id="{4B55242A-A2E7-43FC-BA01-D5E432839B86}"/>
               </a:ext>
             </a:extLst>
           </p:cNvPr>
@@ -1542,7 +1542,7 @@
           <p:cNvPr id="7" name="text">
             <a:extLst xmlns:a="http://schemas.openxmlformats.org/drawingml/2006/main">
               <a:ext uri="{FF2B5EF4-FFF2-40B4-BE49-F238E27FC236}">
-                <a16:creationId xmlns:a16="http://schemas.microsoft.com/office/drawing/2014/main" id="{D68019B7-3775-45CF-AFE9-D1E3D8BF80DF}"/>
+                <a16:creationId xmlns:a16="http://schemas.microsoft.com/office/drawing/2014/main" id="{19B70C3E-9AAA-4DEF-BFFE-7080B7E90C3C}"/>
               </a:ext>
             </a:extLst>
           </p:cNvPr>
@@ -1587,7 +1587,7 @@
           <p:cNvPr id="8" name="text">
             <a:extLst xmlns:a="http://schemas.openxmlformats.org/drawingml/2006/main">
               <a:ext uri="{FF2B5EF4-FFF2-40B4-BE49-F238E27FC236}">
-                <a16:creationId xmlns:a16="http://schemas.microsoft.com/office/drawing/2014/main" id="{49A34542-65FD-48AB-8213-F4AB2CD7BAAC}"/>
+                <a16:creationId xmlns:a16="http://schemas.microsoft.com/office/drawing/2014/main" id="{34DC1663-E759-4191-864D-7F5CED474B2F}"/>
               </a:ext>
             </a:extLst>
           </p:cNvPr>
@@ -1632,7 +1632,7 @@
           <p:cNvPr id="9" name="text">
             <a:extLst xmlns:a="http://schemas.openxmlformats.org/drawingml/2006/main">
               <a:ext uri="{FF2B5EF4-FFF2-40B4-BE49-F238E27FC236}">
-                <a16:creationId xmlns:a16="http://schemas.microsoft.com/office/drawing/2014/main" id="{64FEFCAA-DEDB-4303-A830-3891B74C411B}"/>
+                <a16:creationId xmlns:a16="http://schemas.microsoft.com/office/drawing/2014/main" id="{9B7F134E-AB76-4EBC-AD4D-7A40309C0875}"/>
               </a:ext>
             </a:extLst>
           </p:cNvPr>
@@ -1677,7 +1677,7 @@
           <p:cNvPr id="10" name="text">
             <a:extLst xmlns:a="http://schemas.openxmlformats.org/drawingml/2006/main">
               <a:ext uri="{FF2B5EF4-FFF2-40B4-BE49-F238E27FC236}">
-                <a16:creationId xmlns:a16="http://schemas.microsoft.com/office/drawing/2014/main" id="{86BA2429-1142-4E39-88BE-66204FAE4A0C}"/>
+                <a16:creationId xmlns:a16="http://schemas.microsoft.com/office/drawing/2014/main" id="{81556C51-3053-4953-8428-EEDDEAFF0872}"/>
               </a:ext>
             </a:extLst>
           </p:cNvPr>
@@ -1756,7 +1756,7 @@
           <p:cNvPr id="11" name="text">
             <a:extLst xmlns:a="http://schemas.openxmlformats.org/drawingml/2006/main">
               <a:ext uri="{FF2B5EF4-FFF2-40B4-BE49-F238E27FC236}">
-                <a16:creationId xmlns:a16="http://schemas.microsoft.com/office/drawing/2014/main" id="{39CFA548-CB03-40D7-B6ED-79ABD6BD420A}"/>
+                <a16:creationId xmlns:a16="http://schemas.microsoft.com/office/drawing/2014/main" id="{75DA5FBA-F97B-40EF-9AB0-6651895AB419}"/>
               </a:ext>
             </a:extLst>
           </p:cNvPr>
@@ -1799,7 +1799,7 @@
     </p:spTree>
     <p:extLst>
       <p:ext uri="{BB962C8B-B14F-4D97-AF65-F5344CB8AC3E}">
-        <p14:creationId xmlns:p14="http://schemas.microsoft.com/office/powerpoint/2010/main" val="1813300917"/>
+        <p14:creationId xmlns:p14="http://schemas.microsoft.com/office/powerpoint/2010/main" val="1480307633"/>
       </p:ext>
     </p:extLst>
   </p:cSld>
@@ -1823,7 +1823,7 @@
           <p:cNvPr id="1" name="slide-title">
             <a:extLst xmlns:a="http://schemas.openxmlformats.org/drawingml/2006/main">
               <a:ext uri="{FF2B5EF4-FFF2-40B4-BE49-F238E27FC236}">
-                <a16:creationId xmlns:a16="http://schemas.microsoft.com/office/drawing/2014/main" id="{F0797420-7FA5-44D5-95C1-5AC291E0635F}"/>
+                <a16:creationId xmlns:a16="http://schemas.microsoft.com/office/drawing/2014/main" id="{9805A624-5F23-4229-A87E-4667A4EDC1C1}"/>
               </a:ext>
             </a:extLst>
           </p:cNvPr>
@@ -1868,7 +1868,7 @@
           <p:cNvPr id="2" name="">
             <a:extLst xmlns:a="http://schemas.openxmlformats.org/drawingml/2006/main">
               <a:ext uri="{FF2B5EF4-FFF2-40B4-BE49-F238E27FC236}">
-                <a16:creationId xmlns:a16="http://schemas.microsoft.com/office/drawing/2014/main" id="{EC1E10B6-FEC9-4960-BA20-5BA873B3FB3A}"/>
+                <a16:creationId xmlns:a16="http://schemas.microsoft.com/office/drawing/2014/main" id="{5C69B6E5-7D17-48EE-8816-F83F5F547E29}"/>
               </a:ext>
             </a:extLst>
           </p:cNvPr>
@@ -1901,7 +1901,7 @@
           <p:cNvPr id="3" name="text">
             <a:extLst xmlns:a="http://schemas.openxmlformats.org/drawingml/2006/main">
               <a:ext uri="{FF2B5EF4-FFF2-40B4-BE49-F238E27FC236}">
-                <a16:creationId xmlns:a16="http://schemas.microsoft.com/office/drawing/2014/main" id="{BBC67675-5492-42AF-9231-C62AB1BACB6C}"/>
+                <a16:creationId xmlns:a16="http://schemas.microsoft.com/office/drawing/2014/main" id="{5DE1B278-7BB3-415B-A9B4-041FF83B103C}"/>
               </a:ext>
             </a:extLst>
           </p:cNvPr>
@@ -1946,7 +1946,7 @@
           <p:cNvPr id="4" name="text">
             <a:extLst xmlns:a="http://schemas.openxmlformats.org/drawingml/2006/main">
               <a:ext uri="{FF2B5EF4-FFF2-40B4-BE49-F238E27FC236}">
-                <a16:creationId xmlns:a16="http://schemas.microsoft.com/office/drawing/2014/main" id="{225D1F39-3A66-4B14-AF1F-0BB7995FAA4E}"/>
+                <a16:creationId xmlns:a16="http://schemas.microsoft.com/office/drawing/2014/main" id="{B0084CEE-8FD0-4539-AAD1-4ED147428417}"/>
               </a:ext>
             </a:extLst>
           </p:cNvPr>
@@ -1991,7 +1991,7 @@
           <p:cNvPr id="5" name="text">
             <a:extLst xmlns:a="http://schemas.openxmlformats.org/drawingml/2006/main">
               <a:ext uri="{FF2B5EF4-FFF2-40B4-BE49-F238E27FC236}">
-                <a16:creationId xmlns:a16="http://schemas.microsoft.com/office/drawing/2014/main" id="{3AAB537E-C20A-4097-9FA1-BD19D4FF0536}"/>
+                <a16:creationId xmlns:a16="http://schemas.microsoft.com/office/drawing/2014/main" id="{98440826-69B3-4EEE-A781-416048F62667}"/>
               </a:ext>
             </a:extLst>
           </p:cNvPr>
@@ -2036,7 +2036,7 @@
           <p:cNvPr id="6" name="text">
             <a:extLst xmlns:a="http://schemas.openxmlformats.org/drawingml/2006/main">
               <a:ext uri="{FF2B5EF4-FFF2-40B4-BE49-F238E27FC236}">
-                <a16:creationId xmlns:a16="http://schemas.microsoft.com/office/drawing/2014/main" id="{3E6A9890-351E-41C8-AF02-133AE838E553}"/>
+                <a16:creationId xmlns:a16="http://schemas.microsoft.com/office/drawing/2014/main" id="{06D8CDD5-DC2B-48E8-993F-5F180303CE59}"/>
               </a:ext>
             </a:extLst>
           </p:cNvPr>
@@ -2081,7 +2081,7 @@
           <p:cNvPr id="7" name="text">
             <a:extLst xmlns:a="http://schemas.openxmlformats.org/drawingml/2006/main">
               <a:ext uri="{FF2B5EF4-FFF2-40B4-BE49-F238E27FC236}">
-                <a16:creationId xmlns:a16="http://schemas.microsoft.com/office/drawing/2014/main" id="{5BFBCC3D-759B-44C1-AA16-D292034D590B}"/>
+                <a16:creationId xmlns:a16="http://schemas.microsoft.com/office/drawing/2014/main" id="{6F0ED6F1-1EEF-433E-9F98-DF1B01704E09}"/>
               </a:ext>
             </a:extLst>
           </p:cNvPr>
@@ -2126,7 +2126,7 @@
           <p:cNvPr id="8" name="text">
             <a:extLst xmlns:a="http://schemas.openxmlformats.org/drawingml/2006/main">
               <a:ext uri="{FF2B5EF4-FFF2-40B4-BE49-F238E27FC236}">
-                <a16:creationId xmlns:a16="http://schemas.microsoft.com/office/drawing/2014/main" id="{B63C9955-D306-4C38-9C63-76412D9BC824}"/>
+                <a16:creationId xmlns:a16="http://schemas.microsoft.com/office/drawing/2014/main" id="{47FEB039-CCD0-46A2-9756-5EB13548CD8D}"/>
               </a:ext>
             </a:extLst>
           </p:cNvPr>
@@ -2171,7 +2171,7 @@
           <p:cNvPr id="9" name="text">
             <a:extLst xmlns:a="http://schemas.openxmlformats.org/drawingml/2006/main">
               <a:ext uri="{FF2B5EF4-FFF2-40B4-BE49-F238E27FC236}">
-                <a16:creationId xmlns:a16="http://schemas.microsoft.com/office/drawing/2014/main" id="{C3319A43-388F-4CB9-A8CD-F6B034567B93}"/>
+                <a16:creationId xmlns:a16="http://schemas.microsoft.com/office/drawing/2014/main" id="{A830E088-8CC3-42AC-AE9A-10F6BF61E228}"/>
               </a:ext>
             </a:extLst>
           </p:cNvPr>
@@ -2216,7 +2216,7 @@
           <p:cNvPr id="10" name="text">
             <a:extLst xmlns:a="http://schemas.openxmlformats.org/drawingml/2006/main">
               <a:ext uri="{FF2B5EF4-FFF2-40B4-BE49-F238E27FC236}">
-                <a16:creationId xmlns:a16="http://schemas.microsoft.com/office/drawing/2014/main" id="{B3131B84-40BF-4368-9EBF-0991933C6DE9}"/>
+                <a16:creationId xmlns:a16="http://schemas.microsoft.com/office/drawing/2014/main" id="{D9510F6F-9F31-4AE0-8440-DC9278FC858E}"/>
               </a:ext>
             </a:extLst>
           </p:cNvPr>
@@ -2261,7 +2261,7 @@
           <p:cNvPr id="11" name="text">
             <a:extLst xmlns:a="http://schemas.openxmlformats.org/drawingml/2006/main">
               <a:ext uri="{FF2B5EF4-FFF2-40B4-BE49-F238E27FC236}">
-                <a16:creationId xmlns:a16="http://schemas.microsoft.com/office/drawing/2014/main" id="{BB2085FF-A821-4B0E-8A30-F830A0ECB4A6}"/>
+                <a16:creationId xmlns:a16="http://schemas.microsoft.com/office/drawing/2014/main" id="{DB6DACCD-32B6-4E7F-B1B8-087B37CA4FEA}"/>
               </a:ext>
             </a:extLst>
           </p:cNvPr>
@@ -2306,7 +2306,7 @@
           <p:cNvPr id="12" name="text">
             <a:extLst xmlns:a="http://schemas.openxmlformats.org/drawingml/2006/main">
               <a:ext uri="{FF2B5EF4-FFF2-40B4-BE49-F238E27FC236}">
-                <a16:creationId xmlns:a16="http://schemas.microsoft.com/office/drawing/2014/main" id="{893BD0CA-6936-45C1-802F-1BBC62BAF821}"/>
+                <a16:creationId xmlns:a16="http://schemas.microsoft.com/office/drawing/2014/main" id="{06B04A57-1CB7-4E05-B0DF-97374B64EB3B}"/>
               </a:ext>
             </a:extLst>
           </p:cNvPr>
@@ -2351,7 +2351,7 @@
           <p:cNvPr id="13" name="text">
             <a:extLst xmlns:a="http://schemas.openxmlformats.org/drawingml/2006/main">
               <a:ext uri="{FF2B5EF4-FFF2-40B4-BE49-F238E27FC236}">
-                <a16:creationId xmlns:a16="http://schemas.microsoft.com/office/drawing/2014/main" id="{7DF89151-79DE-44B1-B49D-3C51801C9809}"/>
+                <a16:creationId xmlns:a16="http://schemas.microsoft.com/office/drawing/2014/main" id="{B28C8B7A-6455-434A-9DDA-30297ACE01BF}"/>
               </a:ext>
             </a:extLst>
           </p:cNvPr>
@@ -2396,7 +2396,7 @@
           <p:cNvPr id="14" name="text">
             <a:extLst xmlns:a="http://schemas.openxmlformats.org/drawingml/2006/main">
               <a:ext uri="{FF2B5EF4-FFF2-40B4-BE49-F238E27FC236}">
-                <a16:creationId xmlns:a16="http://schemas.microsoft.com/office/drawing/2014/main" id="{623A8924-FFC6-47E3-9286-B0ED1BF6FF57}"/>
+                <a16:creationId xmlns:a16="http://schemas.microsoft.com/office/drawing/2014/main" id="{EAC5AE82-4FFB-4E98-B14D-E257E9B2CCC8}"/>
               </a:ext>
             </a:extLst>
           </p:cNvPr>
@@ -2441,7 +2441,7 @@
           <p:cNvPr id="15" name="text">
             <a:extLst xmlns:a="http://schemas.openxmlformats.org/drawingml/2006/main">
               <a:ext uri="{FF2B5EF4-FFF2-40B4-BE49-F238E27FC236}">
-                <a16:creationId xmlns:a16="http://schemas.microsoft.com/office/drawing/2014/main" id="{75B29430-C237-4E90-B068-FB064BD7FFD8}"/>
+                <a16:creationId xmlns:a16="http://schemas.microsoft.com/office/drawing/2014/main" id="{F58E9C6C-00A8-4441-9564-5D54F8AF083F}"/>
               </a:ext>
             </a:extLst>
           </p:cNvPr>
@@ -2486,7 +2486,7 @@
           <p:cNvPr id="16" name="text">
             <a:extLst xmlns:a="http://schemas.openxmlformats.org/drawingml/2006/main">
               <a:ext uri="{FF2B5EF4-FFF2-40B4-BE49-F238E27FC236}">
-                <a16:creationId xmlns:a16="http://schemas.microsoft.com/office/drawing/2014/main" id="{EFA8A570-BFF3-4659-9FF0-A653E1448F12}"/>
+                <a16:creationId xmlns:a16="http://schemas.microsoft.com/office/drawing/2014/main" id="{1138518D-C96D-4DD3-9FFC-FC5E66495BD3}"/>
               </a:ext>
             </a:extLst>
           </p:cNvPr>
@@ -2531,7 +2531,7 @@
           <p:cNvPr id="17" name="text">
             <a:extLst xmlns:a="http://schemas.openxmlformats.org/drawingml/2006/main">
               <a:ext uri="{FF2B5EF4-FFF2-40B4-BE49-F238E27FC236}">
-                <a16:creationId xmlns:a16="http://schemas.microsoft.com/office/drawing/2014/main" id="{64361AB2-C00D-488A-805A-25E3406B4344}"/>
+                <a16:creationId xmlns:a16="http://schemas.microsoft.com/office/drawing/2014/main" id="{BFBC9175-A608-49A8-A02C-E96B9F803E09}"/>
               </a:ext>
             </a:extLst>
           </p:cNvPr>
@@ -2576,7 +2576,7 @@
           <p:cNvPr id="18" name="text">
             <a:extLst xmlns:a="http://schemas.openxmlformats.org/drawingml/2006/main">
               <a:ext uri="{FF2B5EF4-FFF2-40B4-BE49-F238E27FC236}">
-                <a16:creationId xmlns:a16="http://schemas.microsoft.com/office/drawing/2014/main" id="{4E41367E-BAE1-47F1-9E86-A4DAB3B1DC45}"/>
+                <a16:creationId xmlns:a16="http://schemas.microsoft.com/office/drawing/2014/main" id="{55EB9308-D4B1-4C69-B2D2-036BA6BD856B}"/>
               </a:ext>
             </a:extLst>
           </p:cNvPr>
@@ -2621,7 +2621,7 @@
           <p:cNvPr id="19" name="text">
             <a:extLst xmlns:a="http://schemas.openxmlformats.org/drawingml/2006/main">
               <a:ext uri="{FF2B5EF4-FFF2-40B4-BE49-F238E27FC236}">
-                <a16:creationId xmlns:a16="http://schemas.microsoft.com/office/drawing/2014/main" id="{96DDE268-A87A-48A1-BA07-F1BE33F107BB}"/>
+                <a16:creationId xmlns:a16="http://schemas.microsoft.com/office/drawing/2014/main" id="{DA667FE4-A1D0-4F8E-9F09-6D5BF7BD7B2C}"/>
               </a:ext>
             </a:extLst>
           </p:cNvPr>
@@ -2666,7 +2666,7 @@
           <p:cNvPr id="20" name="text">
             <a:extLst xmlns:a="http://schemas.openxmlformats.org/drawingml/2006/main">
               <a:ext uri="{FF2B5EF4-FFF2-40B4-BE49-F238E27FC236}">
-                <a16:creationId xmlns:a16="http://schemas.microsoft.com/office/drawing/2014/main" id="{822F66E4-7696-4D88-B02D-A296D485D541}"/>
+                <a16:creationId xmlns:a16="http://schemas.microsoft.com/office/drawing/2014/main" id="{ADD85CF7-11D6-4EA1-9232-9690773BE382}"/>
               </a:ext>
             </a:extLst>
           </p:cNvPr>
@@ -2711,7 +2711,7 @@
           <p:cNvPr id="21" name="text">
             <a:extLst xmlns:a="http://schemas.openxmlformats.org/drawingml/2006/main">
               <a:ext uri="{FF2B5EF4-FFF2-40B4-BE49-F238E27FC236}">
-                <a16:creationId xmlns:a16="http://schemas.microsoft.com/office/drawing/2014/main" id="{357C3825-884E-457F-BFC6-E01C249560A6}"/>
+                <a16:creationId xmlns:a16="http://schemas.microsoft.com/office/drawing/2014/main" id="{590E9D2A-2AA2-4A74-9C0A-68AD51F475B5}"/>
               </a:ext>
             </a:extLst>
           </p:cNvPr>
@@ -2756,7 +2756,7 @@
           <p:cNvPr id="22" name="text">
             <a:extLst xmlns:a="http://schemas.openxmlformats.org/drawingml/2006/main">
               <a:ext uri="{FF2B5EF4-FFF2-40B4-BE49-F238E27FC236}">
-                <a16:creationId xmlns:a16="http://schemas.microsoft.com/office/drawing/2014/main" id="{DBF1B8FA-B594-4889-B87D-F4AC3D0F883A}"/>
+                <a16:creationId xmlns:a16="http://schemas.microsoft.com/office/drawing/2014/main" id="{201390C5-5C61-445E-916F-E063DCE8AEE5}"/>
               </a:ext>
             </a:extLst>
           </p:cNvPr>
@@ -2801,7 +2801,7 @@
           <p:cNvPr id="23" name="text">
             <a:extLst xmlns:a="http://schemas.openxmlformats.org/drawingml/2006/main">
               <a:ext uri="{FF2B5EF4-FFF2-40B4-BE49-F238E27FC236}">
-                <a16:creationId xmlns:a16="http://schemas.microsoft.com/office/drawing/2014/main" id="{5BEEED3F-4D09-4928-9463-B5531EEB28B4}"/>
+                <a16:creationId xmlns:a16="http://schemas.microsoft.com/office/drawing/2014/main" id="{A6873B12-2BAC-4B04-A011-06C79D6DD8BB}"/>
               </a:ext>
             </a:extLst>
           </p:cNvPr>
@@ -2846,7 +2846,7 @@
           <p:cNvPr id="24" name="footer">
             <a:extLst xmlns:a="http://schemas.openxmlformats.org/drawingml/2006/main">
               <a:ext uri="{FF2B5EF4-FFF2-40B4-BE49-F238E27FC236}">
-                <a16:creationId xmlns:a16="http://schemas.microsoft.com/office/drawing/2014/main" id="{ABDDCDE7-9339-4C89-9352-1DBAE48FEAA1}"/>
+                <a16:creationId xmlns:a16="http://schemas.microsoft.com/office/drawing/2014/main" id="{B466C9A1-A466-4E38-8770-592C2EDC130D}"/>
               </a:ext>
             </a:extLst>
           </p:cNvPr>
@@ -2889,7 +2889,7 @@
     </p:spTree>
     <p:extLst>
       <p:ext uri="{BB962C8B-B14F-4D97-AF65-F5344CB8AC3E}">
-        <p14:creationId xmlns:p14="http://schemas.microsoft.com/office/powerpoint/2010/main" val="742344605"/>
+        <p14:creationId xmlns:p14="http://schemas.microsoft.com/office/powerpoint/2010/main" val="475694727"/>
       </p:ext>
     </p:extLst>
   </p:cSld>
@@ -2913,7 +2913,7 @@
           <p:cNvPr id="1" name="text">
             <a:extLst xmlns:a="http://schemas.openxmlformats.org/drawingml/2006/main">
               <a:ext uri="{FF2B5EF4-FFF2-40B4-BE49-F238E27FC236}">
-                <a16:creationId xmlns:a16="http://schemas.microsoft.com/office/drawing/2014/main" id="{B585E75B-907B-4050-BC71-FBAE004798AD}"/>
+                <a16:creationId xmlns:a16="http://schemas.microsoft.com/office/drawing/2014/main" id="{F63D9828-8794-4E34-A8CE-7546B8B6A226}"/>
               </a:ext>
             </a:extLst>
           </p:cNvPr>
@@ -2962,10 +2962,10 @@
           <p:nvPr/>
         </p:nvPicPr>
         <p:blipFill>
-          <a:blip xmlns:r="http://schemas.openxmlformats.org/officeDocument/2006/relationships" xmlns:a="http://schemas.openxmlformats.org/drawingml/2006/main" r:embed="R6445e5e0bcea485c">
+          <a:blip xmlns:r="http://schemas.openxmlformats.org/officeDocument/2006/relationships" xmlns:a="http://schemas.openxmlformats.org/drawingml/2006/main" r:embed="R6369e4fb93ad445a">
             <a:extLst>
               <a:ext uri="{96DAC541-7B7A-43D3-8B79-37D633B846F1}">
-                <asvg:svgBlip xmlns:asvg="http://schemas.microsoft.com/office/drawing/2016/SVG/main" r:embed="R20e1a9a9d816484a"/>
+                <asvg:svgBlip xmlns:asvg="http://schemas.microsoft.com/office/drawing/2016/SVG/main" r:embed="R31be7e70c93a4eec"/>
               </a:ext>
             </a:extLst>
           </a:blip>
@@ -2984,7 +2984,7 @@
     </p:spTree>
     <p:extLst>
       <p:ext uri="{BB962C8B-B14F-4D97-AF65-F5344CB8AC3E}">
-        <p14:creationId xmlns:p14="http://schemas.microsoft.com/office/powerpoint/2010/main" val="337770919"/>
+        <p14:creationId xmlns:p14="http://schemas.microsoft.com/office/powerpoint/2010/main" val="587645902"/>
       </p:ext>
     </p:extLst>
   </p:cSld>
@@ -3008,7 +3008,7 @@
           <p:cNvPr id="1" name="slide-title">
             <a:extLst xmlns:a="http://schemas.openxmlformats.org/drawingml/2006/main">
               <a:ext uri="{FF2B5EF4-FFF2-40B4-BE49-F238E27FC236}">
-                <a16:creationId xmlns:a16="http://schemas.microsoft.com/office/drawing/2014/main" id="{3DFFCDED-38FB-4D24-AE64-499E768501F3}"/>
+                <a16:creationId xmlns:a16="http://schemas.microsoft.com/office/drawing/2014/main" id="{C59AFACB-467E-4287-83A6-22ADEAD06C4C}"/>
               </a:ext>
             </a:extLst>
           </p:cNvPr>
@@ -3053,7 +3053,7 @@
           <p:cNvPr id="2" name="">
             <a:extLst xmlns:a="http://schemas.openxmlformats.org/drawingml/2006/main">
               <a:ext uri="{FF2B5EF4-FFF2-40B4-BE49-F238E27FC236}">
-                <a16:creationId xmlns:a16="http://schemas.microsoft.com/office/drawing/2014/main" id="{69C89832-A8A2-4C4E-AEA0-03073754F658}"/>
+                <a16:creationId xmlns:a16="http://schemas.microsoft.com/office/drawing/2014/main" id="{5A14C01A-FC29-4196-9AAB-C0B7D0D14EDB}"/>
               </a:ext>
             </a:extLst>
           </p:cNvPr>
@@ -3086,7 +3086,7 @@
           <p:cNvPr id="3" name="text">
             <a:extLst xmlns:a="http://schemas.openxmlformats.org/drawingml/2006/main">
               <a:ext uri="{FF2B5EF4-FFF2-40B4-BE49-F238E27FC236}">
-                <a16:creationId xmlns:a16="http://schemas.microsoft.com/office/drawing/2014/main" id="{FEFAA823-D4BE-4C4A-B539-EBEB2ED77055}"/>
+                <a16:creationId xmlns:a16="http://schemas.microsoft.com/office/drawing/2014/main" id="{50831587-21C6-4DE8-9020-1381E7894BA6}"/>
               </a:ext>
             </a:extLst>
           </p:cNvPr>
@@ -3131,7 +3131,7 @@
           <p:cNvPr id="4" name="text">
             <a:extLst xmlns:a="http://schemas.openxmlformats.org/drawingml/2006/main">
               <a:ext uri="{FF2B5EF4-FFF2-40B4-BE49-F238E27FC236}">
-                <a16:creationId xmlns:a16="http://schemas.microsoft.com/office/drawing/2014/main" id="{8437DDD8-D947-48F9-A1A8-4AADFCD3295E}"/>
+                <a16:creationId xmlns:a16="http://schemas.microsoft.com/office/drawing/2014/main" id="{16511CCA-D4F1-4DC8-B9C1-62310E321E98}"/>
               </a:ext>
             </a:extLst>
           </p:cNvPr>
@@ -3176,7 +3176,7 @@
           <p:cNvPr id="5" name="text">
             <a:extLst xmlns:a="http://schemas.openxmlformats.org/drawingml/2006/main">
               <a:ext uri="{FF2B5EF4-FFF2-40B4-BE49-F238E27FC236}">
-                <a16:creationId xmlns:a16="http://schemas.microsoft.com/office/drawing/2014/main" id="{553CF73E-0B2B-41EB-8C52-96F6151DEB76}"/>
+                <a16:creationId xmlns:a16="http://schemas.microsoft.com/office/drawing/2014/main" id="{8899A299-0183-4F3F-9E3C-9F5C8733F58E}"/>
               </a:ext>
             </a:extLst>
           </p:cNvPr>
@@ -3221,7 +3221,7 @@
           <p:cNvPr id="6" name="">
             <a:extLst xmlns:a="http://schemas.openxmlformats.org/drawingml/2006/main">
               <a:ext uri="{FF2B5EF4-FFF2-40B4-BE49-F238E27FC236}">
-                <a16:creationId xmlns:a16="http://schemas.microsoft.com/office/drawing/2014/main" id="{B2FA8523-589C-4E48-AFBA-62B935109DF8}"/>
+                <a16:creationId xmlns:a16="http://schemas.microsoft.com/office/drawing/2014/main" id="{207AB711-1AAA-4E0E-BDE5-9DD0A38FA283}"/>
               </a:ext>
             </a:extLst>
           </p:cNvPr>
@@ -3254,7 +3254,7 @@
           <p:cNvPr id="7" name="text">
             <a:extLst xmlns:a="http://schemas.openxmlformats.org/drawingml/2006/main">
               <a:ext uri="{FF2B5EF4-FFF2-40B4-BE49-F238E27FC236}">
-                <a16:creationId xmlns:a16="http://schemas.microsoft.com/office/drawing/2014/main" id="{10994329-B0D9-4C21-B993-8B723B624172}"/>
+                <a16:creationId xmlns:a16="http://schemas.microsoft.com/office/drawing/2014/main" id="{6313AE85-BC10-4946-8A09-1AD6DDEE7FC3}"/>
               </a:ext>
             </a:extLst>
           </p:cNvPr>
@@ -3299,7 +3299,7 @@
           <p:cNvPr id="8" name="text">
             <a:extLst xmlns:a="http://schemas.openxmlformats.org/drawingml/2006/main">
               <a:ext uri="{FF2B5EF4-FFF2-40B4-BE49-F238E27FC236}">
-                <a16:creationId xmlns:a16="http://schemas.microsoft.com/office/drawing/2014/main" id="{C6C2AB6C-1CC2-4F8D-8B5B-F72FC6AADB8F}"/>
+                <a16:creationId xmlns:a16="http://schemas.microsoft.com/office/drawing/2014/main" id="{88BB14B0-BE08-4856-AC54-EDFEEC76DCC9}"/>
               </a:ext>
             </a:extLst>
           </p:cNvPr>
@@ -3344,7 +3344,7 @@
           <p:cNvPr id="9" name="text">
             <a:extLst xmlns:a="http://schemas.openxmlformats.org/drawingml/2006/main">
               <a:ext uri="{FF2B5EF4-FFF2-40B4-BE49-F238E27FC236}">
-                <a16:creationId xmlns:a16="http://schemas.microsoft.com/office/drawing/2014/main" id="{434F169A-DC41-4A71-B3ED-EC1297FC36D1}"/>
+                <a16:creationId xmlns:a16="http://schemas.microsoft.com/office/drawing/2014/main" id="{A303DFBF-1DAB-421D-AAF8-9A8AB40AC44C}"/>
               </a:ext>
             </a:extLst>
           </p:cNvPr>
@@ -3389,7 +3389,7 @@
           <p:cNvPr id="10" name="">
             <a:extLst xmlns:a="http://schemas.openxmlformats.org/drawingml/2006/main">
               <a:ext uri="{FF2B5EF4-FFF2-40B4-BE49-F238E27FC236}">
-                <a16:creationId xmlns:a16="http://schemas.microsoft.com/office/drawing/2014/main" id="{40B34BD7-D35E-4E61-8F1C-5D1A9068BE73}"/>
+                <a16:creationId xmlns:a16="http://schemas.microsoft.com/office/drawing/2014/main" id="{A22FCCBA-5522-4ACD-9405-3CF3793A5FF6}"/>
               </a:ext>
             </a:extLst>
           </p:cNvPr>
@@ -3422,7 +3422,7 @@
           <p:cNvPr id="11" name="text">
             <a:extLst xmlns:a="http://schemas.openxmlformats.org/drawingml/2006/main">
               <a:ext uri="{FF2B5EF4-FFF2-40B4-BE49-F238E27FC236}">
-                <a16:creationId xmlns:a16="http://schemas.microsoft.com/office/drawing/2014/main" id="{8F6E5D22-234F-497C-A63E-583C5A97818A}"/>
+                <a16:creationId xmlns:a16="http://schemas.microsoft.com/office/drawing/2014/main" id="{B086437C-781E-4C0E-A76B-0DC001DEB291}"/>
               </a:ext>
             </a:extLst>
           </p:cNvPr>
@@ -3467,7 +3467,7 @@
           <p:cNvPr id="12" name="text">
             <a:extLst xmlns:a="http://schemas.openxmlformats.org/drawingml/2006/main">
               <a:ext uri="{FF2B5EF4-FFF2-40B4-BE49-F238E27FC236}">
-                <a16:creationId xmlns:a16="http://schemas.microsoft.com/office/drawing/2014/main" id="{6C79D1B3-B209-4DAA-861F-9250E053E8B7}"/>
+                <a16:creationId xmlns:a16="http://schemas.microsoft.com/office/drawing/2014/main" id="{AC69E5A8-D8C2-4494-B1A4-D028104B06C9}"/>
               </a:ext>
             </a:extLst>
           </p:cNvPr>
@@ -3512,7 +3512,7 @@
           <p:cNvPr id="13" name="text">
             <a:extLst xmlns:a="http://schemas.openxmlformats.org/drawingml/2006/main">
               <a:ext uri="{FF2B5EF4-FFF2-40B4-BE49-F238E27FC236}">
-                <a16:creationId xmlns:a16="http://schemas.microsoft.com/office/drawing/2014/main" id="{664F4F03-E32D-4D6D-8951-F8F6828823BE}"/>
+                <a16:creationId xmlns:a16="http://schemas.microsoft.com/office/drawing/2014/main" id="{17E6963D-EB5D-4671-9E69-570627D5EA9E}"/>
               </a:ext>
             </a:extLst>
           </p:cNvPr>
@@ -3557,7 +3557,7 @@
           <p:cNvPr id="14" name="">
             <a:extLst xmlns:a="http://schemas.openxmlformats.org/drawingml/2006/main">
               <a:ext uri="{FF2B5EF4-FFF2-40B4-BE49-F238E27FC236}">
-                <a16:creationId xmlns:a16="http://schemas.microsoft.com/office/drawing/2014/main" id="{55B779F3-43F5-49F9-AAAE-ECDDFD07A58B}"/>
+                <a16:creationId xmlns:a16="http://schemas.microsoft.com/office/drawing/2014/main" id="{288ECC33-E288-470C-A5A4-BA928CB8F629}"/>
               </a:ext>
             </a:extLst>
           </p:cNvPr>
@@ -3590,7 +3590,7 @@
           <p:cNvPr id="15" name="text">
             <a:extLst xmlns:a="http://schemas.openxmlformats.org/drawingml/2006/main">
               <a:ext uri="{FF2B5EF4-FFF2-40B4-BE49-F238E27FC236}">
-                <a16:creationId xmlns:a16="http://schemas.microsoft.com/office/drawing/2014/main" id="{06229E27-093B-4906-A66A-67809D24B25C}"/>
+                <a16:creationId xmlns:a16="http://schemas.microsoft.com/office/drawing/2014/main" id="{2B58B2EB-ADFD-49C5-8034-4C51A8DB437E}"/>
               </a:ext>
             </a:extLst>
           </p:cNvPr>
@@ -3635,7 +3635,7 @@
           <p:cNvPr id="16" name="text">
             <a:extLst xmlns:a="http://schemas.openxmlformats.org/drawingml/2006/main">
               <a:ext uri="{FF2B5EF4-FFF2-40B4-BE49-F238E27FC236}">
-                <a16:creationId xmlns:a16="http://schemas.microsoft.com/office/drawing/2014/main" id="{8F7F416A-E12A-4C89-BA18-5903D9BCCCFA}"/>
+                <a16:creationId xmlns:a16="http://schemas.microsoft.com/office/drawing/2014/main" id="{16A2D925-8EFD-428A-85C4-7A5C1E1BA2DA}"/>
               </a:ext>
             </a:extLst>
           </p:cNvPr>
@@ -3680,7 +3680,7 @@
           <p:cNvPr id="17" name="text">
             <a:extLst xmlns:a="http://schemas.openxmlformats.org/drawingml/2006/main">
               <a:ext uri="{FF2B5EF4-FFF2-40B4-BE49-F238E27FC236}">
-                <a16:creationId xmlns:a16="http://schemas.microsoft.com/office/drawing/2014/main" id="{C2EB3F77-9D97-4564-8261-BF6237AC703C}"/>
+                <a16:creationId xmlns:a16="http://schemas.microsoft.com/office/drawing/2014/main" id="{BFB1EF9C-538E-4027-BBB4-09D732DEE7FB}"/>
               </a:ext>
             </a:extLst>
           </p:cNvPr>
@@ -3725,7 +3725,7 @@
           <p:cNvPr id="18" name="">
             <a:extLst xmlns:a="http://schemas.openxmlformats.org/drawingml/2006/main">
               <a:ext uri="{FF2B5EF4-FFF2-40B4-BE49-F238E27FC236}">
-                <a16:creationId xmlns:a16="http://schemas.microsoft.com/office/drawing/2014/main" id="{FF36674D-E3A5-4363-9B82-E8C0CB02E0E5}"/>
+                <a16:creationId xmlns:a16="http://schemas.microsoft.com/office/drawing/2014/main" id="{CC4D9497-3972-4CE1-B59D-566CD2854985}"/>
               </a:ext>
             </a:extLst>
           </p:cNvPr>
@@ -3758,7 +3758,7 @@
           <p:cNvPr id="19" name="text">
             <a:extLst xmlns:a="http://schemas.openxmlformats.org/drawingml/2006/main">
               <a:ext uri="{FF2B5EF4-FFF2-40B4-BE49-F238E27FC236}">
-                <a16:creationId xmlns:a16="http://schemas.microsoft.com/office/drawing/2014/main" id="{DF115730-C2EB-454D-A4C3-C164F68328B4}"/>
+                <a16:creationId xmlns:a16="http://schemas.microsoft.com/office/drawing/2014/main" id="{E2437FE8-CE0A-4089-A3E3-B1C08DCD4465}"/>
               </a:ext>
             </a:extLst>
           </p:cNvPr>
@@ -3803,7 +3803,7 @@
           <p:cNvPr id="20" name="text">
             <a:extLst xmlns:a="http://schemas.openxmlformats.org/drawingml/2006/main">
               <a:ext uri="{FF2B5EF4-FFF2-40B4-BE49-F238E27FC236}">
-                <a16:creationId xmlns:a16="http://schemas.microsoft.com/office/drawing/2014/main" id="{1CE523DB-86C1-4AF3-969C-00CA60E9B6A1}"/>
+                <a16:creationId xmlns:a16="http://schemas.microsoft.com/office/drawing/2014/main" id="{57B4A030-11BA-4F41-B6C2-BD7AAA64726A}"/>
               </a:ext>
             </a:extLst>
           </p:cNvPr>
@@ -3848,7 +3848,7 @@
           <p:cNvPr id="21" name="text">
             <a:extLst xmlns:a="http://schemas.openxmlformats.org/drawingml/2006/main">
               <a:ext uri="{FF2B5EF4-FFF2-40B4-BE49-F238E27FC236}">
-                <a16:creationId xmlns:a16="http://schemas.microsoft.com/office/drawing/2014/main" id="{10704C54-FF1D-4EDC-9209-97AFC19ADC94}"/>
+                <a16:creationId xmlns:a16="http://schemas.microsoft.com/office/drawing/2014/main" id="{19DBE548-0119-4945-AFC5-73A3BAE34CED}"/>
               </a:ext>
             </a:extLst>
           </p:cNvPr>
@@ -3893,7 +3893,7 @@
           <p:cNvPr id="22" name="">
             <a:extLst xmlns:a="http://schemas.openxmlformats.org/drawingml/2006/main">
               <a:ext uri="{FF2B5EF4-FFF2-40B4-BE49-F238E27FC236}">
-                <a16:creationId xmlns:a16="http://schemas.microsoft.com/office/drawing/2014/main" id="{4291D6FA-675D-4B61-9E36-92696C8A5997}"/>
+                <a16:creationId xmlns:a16="http://schemas.microsoft.com/office/drawing/2014/main" id="{9BF519EF-4D98-438C-8A49-0E21773937F9}"/>
               </a:ext>
             </a:extLst>
           </p:cNvPr>
@@ -3926,7 +3926,7 @@
           <p:cNvPr id="23" name="text">
             <a:extLst xmlns:a="http://schemas.openxmlformats.org/drawingml/2006/main">
               <a:ext uri="{FF2B5EF4-FFF2-40B4-BE49-F238E27FC236}">
-                <a16:creationId xmlns:a16="http://schemas.microsoft.com/office/drawing/2014/main" id="{7472E3AA-680C-4815-9BE4-D5D669E85F28}"/>
+                <a16:creationId xmlns:a16="http://schemas.microsoft.com/office/drawing/2014/main" id="{67C5B531-C5B3-4EBB-AE43-1DB55371CA46}"/>
               </a:ext>
             </a:extLst>
           </p:cNvPr>
@@ -3971,7 +3971,7 @@
           <p:cNvPr id="24" name="text">
             <a:extLst xmlns:a="http://schemas.openxmlformats.org/drawingml/2006/main">
               <a:ext uri="{FF2B5EF4-FFF2-40B4-BE49-F238E27FC236}">
-                <a16:creationId xmlns:a16="http://schemas.microsoft.com/office/drawing/2014/main" id="{60FD1278-AB8D-4E01-84B3-DDD5C0E47EDA}"/>
+                <a16:creationId xmlns:a16="http://schemas.microsoft.com/office/drawing/2014/main" id="{2DFE3F7C-0097-463D-B110-FC3EE37E0E5E}"/>
               </a:ext>
             </a:extLst>
           </p:cNvPr>
@@ -4016,7 +4016,7 @@
           <p:cNvPr id="25" name="text">
             <a:extLst xmlns:a="http://schemas.openxmlformats.org/drawingml/2006/main">
               <a:ext uri="{FF2B5EF4-FFF2-40B4-BE49-F238E27FC236}">
-                <a16:creationId xmlns:a16="http://schemas.microsoft.com/office/drawing/2014/main" id="{2884A3CC-496D-453A-92EE-B91F1A632308}"/>
+                <a16:creationId xmlns:a16="http://schemas.microsoft.com/office/drawing/2014/main" id="{6A05D949-8C77-44A0-A497-8F695F724019}"/>
               </a:ext>
             </a:extLst>
           </p:cNvPr>
@@ -4061,7 +4061,7 @@
           <p:cNvPr id="26" name="">
             <a:extLst xmlns:a="http://schemas.openxmlformats.org/drawingml/2006/main">
               <a:ext uri="{FF2B5EF4-FFF2-40B4-BE49-F238E27FC236}">
-                <a16:creationId xmlns:a16="http://schemas.microsoft.com/office/drawing/2014/main" id="{1CE10ECA-0FF5-4313-AA9A-E364AA6CA2FC}"/>
+                <a16:creationId xmlns:a16="http://schemas.microsoft.com/office/drawing/2014/main" id="{74030AB3-4E64-4D8A-A712-95F5E4F737FD}"/>
               </a:ext>
             </a:extLst>
           </p:cNvPr>
@@ -4094,7 +4094,7 @@
           <p:cNvPr id="27" name="text">
             <a:extLst xmlns:a="http://schemas.openxmlformats.org/drawingml/2006/main">
               <a:ext uri="{FF2B5EF4-FFF2-40B4-BE49-F238E27FC236}">
-                <a16:creationId xmlns:a16="http://schemas.microsoft.com/office/drawing/2014/main" id="{4D11D1CD-010C-42A8-8B2F-183610D8864E}"/>
+                <a16:creationId xmlns:a16="http://schemas.microsoft.com/office/drawing/2014/main" id="{8DE72B15-0439-4782-83F3-FE9A124E9E0F}"/>
               </a:ext>
             </a:extLst>
           </p:cNvPr>
@@ -4139,7 +4139,7 @@
           <p:cNvPr id="28" name="text">
             <a:extLst xmlns:a="http://schemas.openxmlformats.org/drawingml/2006/main">
               <a:ext uri="{FF2B5EF4-FFF2-40B4-BE49-F238E27FC236}">
-                <a16:creationId xmlns:a16="http://schemas.microsoft.com/office/drawing/2014/main" id="{F7B499AE-05DF-4048-AF84-68EB0440EDFB}"/>
+                <a16:creationId xmlns:a16="http://schemas.microsoft.com/office/drawing/2014/main" id="{9512BEB4-3DDA-47F7-A350-A95486910F35}"/>
               </a:ext>
             </a:extLst>
           </p:cNvPr>
@@ -4184,7 +4184,7 @@
           <p:cNvPr id="29" name="text">
             <a:extLst xmlns:a="http://schemas.openxmlformats.org/drawingml/2006/main">
               <a:ext uri="{FF2B5EF4-FFF2-40B4-BE49-F238E27FC236}">
-                <a16:creationId xmlns:a16="http://schemas.microsoft.com/office/drawing/2014/main" id="{DFF15A6F-5E72-4044-9EC7-4B17C0B03CDA}"/>
+                <a16:creationId xmlns:a16="http://schemas.microsoft.com/office/drawing/2014/main" id="{F7B9B3C9-ADBE-439F-854D-5D7F11F5C476}"/>
               </a:ext>
             </a:extLst>
           </p:cNvPr>
@@ -4229,7 +4229,7 @@
           <p:cNvPr id="30" name="">
             <a:extLst xmlns:a="http://schemas.openxmlformats.org/drawingml/2006/main">
               <a:ext uri="{FF2B5EF4-FFF2-40B4-BE49-F238E27FC236}">
-                <a16:creationId xmlns:a16="http://schemas.microsoft.com/office/drawing/2014/main" id="{F232C585-6AF7-4820-B960-59E13A2E674D}"/>
+                <a16:creationId xmlns:a16="http://schemas.microsoft.com/office/drawing/2014/main" id="{3BF4958F-E7A6-4247-9B9D-FBEE389D0595}"/>
               </a:ext>
             </a:extLst>
           </p:cNvPr>
@@ -4262,7 +4262,7 @@
           <p:cNvPr id="31" name="text">
             <a:extLst xmlns:a="http://schemas.openxmlformats.org/drawingml/2006/main">
               <a:ext uri="{FF2B5EF4-FFF2-40B4-BE49-F238E27FC236}">
-                <a16:creationId xmlns:a16="http://schemas.microsoft.com/office/drawing/2014/main" id="{E94701C1-8698-4CA5-B6C8-23A136684890}"/>
+                <a16:creationId xmlns:a16="http://schemas.microsoft.com/office/drawing/2014/main" id="{B79E21CA-5014-4732-AE80-100B1F37CA78}"/>
               </a:ext>
             </a:extLst>
           </p:cNvPr>
@@ -4307,7 +4307,7 @@
           <p:cNvPr id="32" name="text">
             <a:extLst xmlns:a="http://schemas.openxmlformats.org/drawingml/2006/main">
               <a:ext uri="{FF2B5EF4-FFF2-40B4-BE49-F238E27FC236}">
-                <a16:creationId xmlns:a16="http://schemas.microsoft.com/office/drawing/2014/main" id="{3CE3B58A-F832-4E0E-83F1-A50B908FC255}"/>
+                <a16:creationId xmlns:a16="http://schemas.microsoft.com/office/drawing/2014/main" id="{AF0F8D58-56F3-4123-8A1B-E5661B98108B}"/>
               </a:ext>
             </a:extLst>
           </p:cNvPr>
@@ -4352,7 +4352,7 @@
           <p:cNvPr id="33" name="text">
             <a:extLst xmlns:a="http://schemas.openxmlformats.org/drawingml/2006/main">
               <a:ext uri="{FF2B5EF4-FFF2-40B4-BE49-F238E27FC236}">
-                <a16:creationId xmlns:a16="http://schemas.microsoft.com/office/drawing/2014/main" id="{FB0E0AB6-8417-4D20-8C37-0ACC4243AD10}"/>
+                <a16:creationId xmlns:a16="http://schemas.microsoft.com/office/drawing/2014/main" id="{041F4AA0-A309-4E06-B382-D9B9DD3F2EC5}"/>
               </a:ext>
             </a:extLst>
           </p:cNvPr>
@@ -4397,7 +4397,7 @@
           <p:cNvPr id="34" name="">
             <a:extLst xmlns:a="http://schemas.openxmlformats.org/drawingml/2006/main">
               <a:ext uri="{FF2B5EF4-FFF2-40B4-BE49-F238E27FC236}">
-                <a16:creationId xmlns:a16="http://schemas.microsoft.com/office/drawing/2014/main" id="{1973E01E-4548-43BD-BCE5-6089972EFC73}"/>
+                <a16:creationId xmlns:a16="http://schemas.microsoft.com/office/drawing/2014/main" id="{28A2A9D3-60DF-466B-B21E-EF78A8114BEC}"/>
               </a:ext>
             </a:extLst>
           </p:cNvPr>
@@ -4434,10 +4434,10 @@
           <p:nvPr/>
         </p:nvPicPr>
         <p:blipFill>
-          <a:blip xmlns:r="http://schemas.openxmlformats.org/officeDocument/2006/relationships" xmlns:a="http://schemas.openxmlformats.org/drawingml/2006/main" r:embed="R9e1aa60880434af5">
+          <a:blip xmlns:r="http://schemas.openxmlformats.org/officeDocument/2006/relationships" xmlns:a="http://schemas.openxmlformats.org/drawingml/2006/main" r:embed="Rbfc31c5d9bb849e1">
             <a:extLst>
               <a:ext uri="{96DAC541-7B7A-43D3-8B79-37D633B846F1}">
-                <asvg:svgBlip xmlns:asvg="http://schemas.microsoft.com/office/drawing/2016/SVG/main" r:embed="R65fd21712aef4f64"/>
+                <asvg:svgBlip xmlns:asvg="http://schemas.microsoft.com/office/drawing/2016/SVG/main" r:embed="R23cfbdb480f3402c"/>
               </a:ext>
             </a:extLst>
           </a:blip>
@@ -4458,7 +4458,7 @@
           <p:cNvPr id="36" name="footer">
             <a:extLst xmlns:a="http://schemas.openxmlformats.org/drawingml/2006/main">
               <a:ext uri="{FF2B5EF4-FFF2-40B4-BE49-F238E27FC236}">
-                <a16:creationId xmlns:a16="http://schemas.microsoft.com/office/drawing/2014/main" id="{024A5740-8F06-4980-B528-5E5EB65BF9FC}"/>
+                <a16:creationId xmlns:a16="http://schemas.microsoft.com/office/drawing/2014/main" id="{1E4B1716-1116-40C3-B1F5-7B3D78BEBDAC}"/>
               </a:ext>
             </a:extLst>
           </p:cNvPr>
@@ -4501,7 +4501,7 @@
     </p:spTree>
     <p:extLst>
       <p:ext uri="{BB962C8B-B14F-4D97-AF65-F5344CB8AC3E}">
-        <p14:creationId xmlns:p14="http://schemas.microsoft.com/office/powerpoint/2010/main" val="250520685"/>
+        <p14:creationId xmlns:p14="http://schemas.microsoft.com/office/powerpoint/2010/main" val="104596594"/>
       </p:ext>
     </p:extLst>
   </p:cSld>
@@ -4525,7 +4525,7 @@
           <p:cNvPr id="1" name="slide-title">
             <a:extLst xmlns:a="http://schemas.openxmlformats.org/drawingml/2006/main">
               <a:ext uri="{FF2B5EF4-FFF2-40B4-BE49-F238E27FC236}">
-                <a16:creationId xmlns:a16="http://schemas.microsoft.com/office/drawing/2014/main" id="{ABCCC0FB-30E4-4FB0-952C-570FF1085AC4}"/>
+                <a16:creationId xmlns:a16="http://schemas.microsoft.com/office/drawing/2014/main" id="{5C2A309F-C8EE-430C-8518-4F1ACEE028E8}"/>
               </a:ext>
             </a:extLst>
           </p:cNvPr>
@@ -4570,7 +4570,7 @@
           <p:cNvPr id="2" name="">
             <a:extLst xmlns:a="http://schemas.openxmlformats.org/drawingml/2006/main">
               <a:ext uri="{FF2B5EF4-FFF2-40B4-BE49-F238E27FC236}">
-                <a16:creationId xmlns:a16="http://schemas.microsoft.com/office/drawing/2014/main" id="{2C9B5F22-18A0-4264-A555-0C809755646A}"/>
+                <a16:creationId xmlns:a16="http://schemas.microsoft.com/office/drawing/2014/main" id="{17134F64-926D-4550-9AFC-C1657E8BC666}"/>
               </a:ext>
             </a:extLst>
           </p:cNvPr>
@@ -4607,10 +4607,10 @@
           <p:nvPr/>
         </p:nvPicPr>
         <p:blipFill>
-          <a:blip xmlns:r="http://schemas.openxmlformats.org/officeDocument/2006/relationships" xmlns:a="http://schemas.openxmlformats.org/drawingml/2006/main" r:embed="R27c9c026265f463a">
+          <a:blip xmlns:r="http://schemas.openxmlformats.org/officeDocument/2006/relationships" xmlns:a="http://schemas.openxmlformats.org/drawingml/2006/main" r:embed="Rc807ed92e9404a96">
             <a:extLst>
               <a:ext uri="{96DAC541-7B7A-43D3-8B79-37D633B846F1}">
-                <asvg:svgBlip xmlns:asvg="http://schemas.microsoft.com/office/drawing/2016/SVG/main" r:embed="R6a1fddc0ea7d4ab3"/>
+                <asvg:svgBlip xmlns:asvg="http://schemas.microsoft.com/office/drawing/2016/SVG/main" r:embed="Rbb94c115a521473f"/>
               </a:ext>
             </a:extLst>
           </a:blip>
@@ -4631,7 +4631,7 @@
           <p:cNvPr id="4" name="text">
             <a:extLst xmlns:a="http://schemas.openxmlformats.org/drawingml/2006/main">
               <a:ext uri="{FF2B5EF4-FFF2-40B4-BE49-F238E27FC236}">
-                <a16:creationId xmlns:a16="http://schemas.microsoft.com/office/drawing/2014/main" id="{2D058512-5B07-4D7E-9333-9665C1EDDC5D}"/>
+                <a16:creationId xmlns:a16="http://schemas.microsoft.com/office/drawing/2014/main" id="{B928C1E1-B8CB-4871-9786-41AD99BEBF8C}"/>
               </a:ext>
             </a:extLst>
           </p:cNvPr>
@@ -4676,7 +4676,7 @@
           <p:cNvPr id="5" name="text">
             <a:extLst xmlns:a="http://schemas.openxmlformats.org/drawingml/2006/main">
               <a:ext uri="{FF2B5EF4-FFF2-40B4-BE49-F238E27FC236}">
-                <a16:creationId xmlns:a16="http://schemas.microsoft.com/office/drawing/2014/main" id="{ADE4ACE1-2335-4D56-A93F-F6641AD479C1}"/>
+                <a16:creationId xmlns:a16="http://schemas.microsoft.com/office/drawing/2014/main" id="{81A391CA-DD8F-4E47-9894-9364B736B2B3}"/>
               </a:ext>
             </a:extLst>
           </p:cNvPr>
@@ -4721,7 +4721,7 @@
           <p:cNvPr id="6" name="text">
             <a:extLst xmlns:a="http://schemas.openxmlformats.org/drawingml/2006/main">
               <a:ext uri="{FF2B5EF4-FFF2-40B4-BE49-F238E27FC236}">
-                <a16:creationId xmlns:a16="http://schemas.microsoft.com/office/drawing/2014/main" id="{0FE5DFA3-8017-491C-90A8-1F6BE073E972}"/>
+                <a16:creationId xmlns:a16="http://schemas.microsoft.com/office/drawing/2014/main" id="{99B4C632-E442-4230-BB06-AB9A23F22715}"/>
               </a:ext>
             </a:extLst>
           </p:cNvPr>
@@ -4766,7 +4766,7 @@
           <p:cNvPr id="7" name="text">
             <a:extLst xmlns:a="http://schemas.openxmlformats.org/drawingml/2006/main">
               <a:ext uri="{FF2B5EF4-FFF2-40B4-BE49-F238E27FC236}">
-                <a16:creationId xmlns:a16="http://schemas.microsoft.com/office/drawing/2014/main" id="{70E1AF53-E4C1-402F-9C59-E4BBB57B4F59}"/>
+                <a16:creationId xmlns:a16="http://schemas.microsoft.com/office/drawing/2014/main" id="{67809EA5-A8A1-48F9-8ABF-7450733B04DD}"/>
               </a:ext>
             </a:extLst>
           </p:cNvPr>
@@ -4811,7 +4811,7 @@
           <p:cNvPr id="8" name="text">
             <a:extLst xmlns:a="http://schemas.openxmlformats.org/drawingml/2006/main">
               <a:ext uri="{FF2B5EF4-FFF2-40B4-BE49-F238E27FC236}">
-                <a16:creationId xmlns:a16="http://schemas.microsoft.com/office/drawing/2014/main" id="{618FF92E-6C5D-4801-8F51-DC56864F6F2F}"/>
+                <a16:creationId xmlns:a16="http://schemas.microsoft.com/office/drawing/2014/main" id="{B7BDE303-B808-49E3-B1FC-3D26F8154EBA}"/>
               </a:ext>
             </a:extLst>
           </p:cNvPr>
@@ -4856,7 +4856,7 @@
           <p:cNvPr id="9" name="text">
             <a:extLst xmlns:a="http://schemas.openxmlformats.org/drawingml/2006/main">
               <a:ext uri="{FF2B5EF4-FFF2-40B4-BE49-F238E27FC236}">
-                <a16:creationId xmlns:a16="http://schemas.microsoft.com/office/drawing/2014/main" id="{32B4464D-1DDC-4182-A97D-DF7E47CB7CA6}"/>
+                <a16:creationId xmlns:a16="http://schemas.microsoft.com/office/drawing/2014/main" id="{6AF673A1-EA8C-412A-BEFC-47B7CF4501EF}"/>
               </a:ext>
             </a:extLst>
           </p:cNvPr>
@@ -4901,7 +4901,7 @@
           <p:cNvPr id="10" name="text">
             <a:extLst xmlns:a="http://schemas.openxmlformats.org/drawingml/2006/main">
               <a:ext uri="{FF2B5EF4-FFF2-40B4-BE49-F238E27FC236}">
-                <a16:creationId xmlns:a16="http://schemas.microsoft.com/office/drawing/2014/main" id="{F155B22B-11EA-4960-ADDE-D71875C6D2AB}"/>
+                <a16:creationId xmlns:a16="http://schemas.microsoft.com/office/drawing/2014/main" id="{0E8A856B-AE6D-42B8-AE3C-C47D3DC252C8}"/>
               </a:ext>
             </a:extLst>
           </p:cNvPr>
@@ -4936,7 +4936,7 @@
                   <a:srgbClr val="526772"/>
                 </a:solidFill>
               </a:rPr>
-              <a:t>ModelSim: 22 CPU/PIC configurations   ·   Verilator: 16 benches with assertions</a:t>
+              <a:t>ModelSim: 39 CPU/PIC runs   ·   Verilator: 17 benches, 53 runs with assertions</a:t>
             </a:r>
           </a:p>
         </p:txBody>
@@ -4946,7 +4946,7 @@
           <p:cNvPr id="11" name="footer">
             <a:extLst xmlns:a="http://schemas.openxmlformats.org/drawingml/2006/main">
               <a:ext uri="{FF2B5EF4-FFF2-40B4-BE49-F238E27FC236}">
-                <a16:creationId xmlns:a16="http://schemas.microsoft.com/office/drawing/2014/main" id="{F9D09F87-2FA3-40CD-AA89-4DEBF78D4254}"/>
+                <a16:creationId xmlns:a16="http://schemas.microsoft.com/office/drawing/2014/main" id="{B16960EF-F958-4C91-8A5A-2683B81378C9}"/>
               </a:ext>
             </a:extLst>
           </p:cNvPr>
@@ -4989,7 +4989,7 @@
     </p:spTree>
     <p:extLst>
       <p:ext uri="{BB962C8B-B14F-4D97-AF65-F5344CB8AC3E}">
-        <p14:creationId xmlns:p14="http://schemas.microsoft.com/office/powerpoint/2010/main" val="1475277465"/>
+        <p14:creationId xmlns:p14="http://schemas.microsoft.com/office/powerpoint/2010/main" val="1205409733"/>
       </p:ext>
     </p:extLst>
   </p:cSld>
@@ -5013,7 +5013,7 @@
           <p:cNvPr id="1" name="slide-title">
             <a:extLst xmlns:a="http://schemas.openxmlformats.org/drawingml/2006/main">
               <a:ext uri="{FF2B5EF4-FFF2-40B4-BE49-F238E27FC236}">
-                <a16:creationId xmlns:a16="http://schemas.microsoft.com/office/drawing/2014/main" id="{5D65EC73-11A9-4715-92C3-492B24E31E23}"/>
+                <a16:creationId xmlns:a16="http://schemas.microsoft.com/office/drawing/2014/main" id="{61B8433E-5981-4E36-8157-B1782B3DD457}"/>
               </a:ext>
             </a:extLst>
           </p:cNvPr>
@@ -5058,7 +5058,7 @@
           <p:cNvPr id="2" name="">
             <a:extLst xmlns:a="http://schemas.openxmlformats.org/drawingml/2006/main">
               <a:ext uri="{FF2B5EF4-FFF2-40B4-BE49-F238E27FC236}">
-                <a16:creationId xmlns:a16="http://schemas.microsoft.com/office/drawing/2014/main" id="{9D2D45E2-6E74-450F-AD6A-09BB4406E5AD}"/>
+                <a16:creationId xmlns:a16="http://schemas.microsoft.com/office/drawing/2014/main" id="{0BACF396-908F-475B-9510-A01C3D958E94}"/>
               </a:ext>
             </a:extLst>
           </p:cNvPr>
@@ -5095,10 +5095,10 @@
           <p:nvPr/>
         </p:nvPicPr>
         <p:blipFill>
-          <a:blip xmlns:r="http://schemas.openxmlformats.org/officeDocument/2006/relationships" xmlns:a="http://schemas.openxmlformats.org/drawingml/2006/main" r:embed="Rba3a372d9add464e">
+          <a:blip xmlns:r="http://schemas.openxmlformats.org/officeDocument/2006/relationships" xmlns:a="http://schemas.openxmlformats.org/drawingml/2006/main" r:embed="R0935a1c42ede4977">
             <a:extLst>
               <a:ext uri="{96DAC541-7B7A-43D3-8B79-37D633B846F1}">
-                <asvg:svgBlip xmlns:asvg="http://schemas.microsoft.com/office/drawing/2016/SVG/main" r:embed="Radd4ddb0e6c64674"/>
+                <asvg:svgBlip xmlns:asvg="http://schemas.microsoft.com/office/drawing/2016/SVG/main" r:embed="R5b1b5666a8894955"/>
               </a:ext>
             </a:extLst>
           </a:blip>
@@ -5119,7 +5119,7 @@
           <p:cNvPr id="4" name="text">
             <a:extLst xmlns:a="http://schemas.openxmlformats.org/drawingml/2006/main">
               <a:ext uri="{FF2B5EF4-FFF2-40B4-BE49-F238E27FC236}">
-                <a16:creationId xmlns:a16="http://schemas.microsoft.com/office/drawing/2014/main" id="{DAAFA727-5BDF-467B-A1E9-86A432EFD126}"/>
+                <a16:creationId xmlns:a16="http://schemas.microsoft.com/office/drawing/2014/main" id="{09913977-80B3-4A29-A48D-4E560FAC7DF4}"/>
               </a:ext>
             </a:extLst>
           </p:cNvPr>
@@ -5164,7 +5164,7 @@
           <p:cNvPr id="5" name="text">
             <a:extLst xmlns:a="http://schemas.openxmlformats.org/drawingml/2006/main">
               <a:ext uri="{FF2B5EF4-FFF2-40B4-BE49-F238E27FC236}">
-                <a16:creationId xmlns:a16="http://schemas.microsoft.com/office/drawing/2014/main" id="{CC78E01D-8A74-4540-A2F1-420455125FBD}"/>
+                <a16:creationId xmlns:a16="http://schemas.microsoft.com/office/drawing/2014/main" id="{88C22037-E420-468F-9B0B-DAFFF31394F1}"/>
               </a:ext>
             </a:extLst>
           </p:cNvPr>
@@ -5209,7 +5209,7 @@
           <p:cNvPr id="6" name="text">
             <a:extLst xmlns:a="http://schemas.openxmlformats.org/drawingml/2006/main">
               <a:ext uri="{FF2B5EF4-FFF2-40B4-BE49-F238E27FC236}">
-                <a16:creationId xmlns:a16="http://schemas.microsoft.com/office/drawing/2014/main" id="{B80381EC-B363-43F0-BA08-971E58E16937}"/>
+                <a16:creationId xmlns:a16="http://schemas.microsoft.com/office/drawing/2014/main" id="{7541F69F-DE6F-47C9-B40A-42F8A19B33AA}"/>
               </a:ext>
             </a:extLst>
           </p:cNvPr>
@@ -5254,7 +5254,7 @@
           <p:cNvPr id="7" name="text">
             <a:extLst xmlns:a="http://schemas.openxmlformats.org/drawingml/2006/main">
               <a:ext uri="{FF2B5EF4-FFF2-40B4-BE49-F238E27FC236}">
-                <a16:creationId xmlns:a16="http://schemas.microsoft.com/office/drawing/2014/main" id="{BD00611D-6B59-4B50-9CF8-51217C601E54}"/>
+                <a16:creationId xmlns:a16="http://schemas.microsoft.com/office/drawing/2014/main" id="{D04EF5BE-B21C-42E6-AEE0-F7807951ECDD}"/>
               </a:ext>
             </a:extLst>
           </p:cNvPr>
@@ -5299,7 +5299,7 @@
           <p:cNvPr id="8" name="text">
             <a:extLst xmlns:a="http://schemas.openxmlformats.org/drawingml/2006/main">
               <a:ext uri="{FF2B5EF4-FFF2-40B4-BE49-F238E27FC236}">
-                <a16:creationId xmlns:a16="http://schemas.microsoft.com/office/drawing/2014/main" id="{82F05E07-2BB4-4C66-8859-EC247803EBD3}"/>
+                <a16:creationId xmlns:a16="http://schemas.microsoft.com/office/drawing/2014/main" id="{6C6AA723-551F-4236-B089-38C39253F682}"/>
               </a:ext>
             </a:extLst>
           </p:cNvPr>
@@ -5344,7 +5344,7 @@
           <p:cNvPr id="9" name="text">
             <a:extLst xmlns:a="http://schemas.openxmlformats.org/drawingml/2006/main">
               <a:ext uri="{FF2B5EF4-FFF2-40B4-BE49-F238E27FC236}">
-                <a16:creationId xmlns:a16="http://schemas.microsoft.com/office/drawing/2014/main" id="{B2964AB2-8DDF-470A-AE79-E08C04CA7724}"/>
+                <a16:creationId xmlns:a16="http://schemas.microsoft.com/office/drawing/2014/main" id="{15DFD754-001C-4224-AA89-6D3B7E889432}"/>
               </a:ext>
             </a:extLst>
           </p:cNvPr>
@@ -5389,7 +5389,7 @@
           <p:cNvPr id="10" name="text">
             <a:extLst xmlns:a="http://schemas.openxmlformats.org/drawingml/2006/main">
               <a:ext uri="{FF2B5EF4-FFF2-40B4-BE49-F238E27FC236}">
-                <a16:creationId xmlns:a16="http://schemas.microsoft.com/office/drawing/2014/main" id="{B30F9C29-D52F-4DC2-A27D-22AF89EA5466}"/>
+                <a16:creationId xmlns:a16="http://schemas.microsoft.com/office/drawing/2014/main" id="{C3CB6EFC-8F96-40B4-B7C6-4297871CB070}"/>
               </a:ext>
             </a:extLst>
           </p:cNvPr>
@@ -5434,7 +5434,7 @@
           <p:cNvPr id="11" name="text">
             <a:extLst xmlns:a="http://schemas.openxmlformats.org/drawingml/2006/main">
               <a:ext uri="{FF2B5EF4-FFF2-40B4-BE49-F238E27FC236}">
-                <a16:creationId xmlns:a16="http://schemas.microsoft.com/office/drawing/2014/main" id="{FF7685F5-A6AF-4FA7-878F-B8BC84CC8759}"/>
+                <a16:creationId xmlns:a16="http://schemas.microsoft.com/office/drawing/2014/main" id="{3A812575-CD80-4A9B-A8B5-0FD97FA8EBF3}"/>
               </a:ext>
             </a:extLst>
           </p:cNvPr>
@@ -5479,7 +5479,7 @@
           <p:cNvPr id="12" name="text">
             <a:extLst xmlns:a="http://schemas.openxmlformats.org/drawingml/2006/main">
               <a:ext uri="{FF2B5EF4-FFF2-40B4-BE49-F238E27FC236}">
-                <a16:creationId xmlns:a16="http://schemas.microsoft.com/office/drawing/2014/main" id="{33617B33-69A9-4EE2-B0BE-44351CC9CED9}"/>
+                <a16:creationId xmlns:a16="http://schemas.microsoft.com/office/drawing/2014/main" id="{74AEFD99-A2E7-4CC2-A28F-ACB88ED63C2D}"/>
               </a:ext>
             </a:extLst>
           </p:cNvPr>
@@ -5524,7 +5524,7 @@
           <p:cNvPr id="13" name="footer">
             <a:extLst xmlns:a="http://schemas.openxmlformats.org/drawingml/2006/main">
               <a:ext uri="{FF2B5EF4-FFF2-40B4-BE49-F238E27FC236}">
-                <a16:creationId xmlns:a16="http://schemas.microsoft.com/office/drawing/2014/main" id="{49FA9E03-945E-4D19-A643-40B32C92E73A}"/>
+                <a16:creationId xmlns:a16="http://schemas.microsoft.com/office/drawing/2014/main" id="{A041C404-9003-4F9E-B292-4646F3454383}"/>
               </a:ext>
             </a:extLst>
           </p:cNvPr>
@@ -5567,7 +5567,7 @@
     </p:spTree>
     <p:extLst>
       <p:ext uri="{BB962C8B-B14F-4D97-AF65-F5344CB8AC3E}">
-        <p14:creationId xmlns:p14="http://schemas.microsoft.com/office/powerpoint/2010/main" val="943249602"/>
+        <p14:creationId xmlns:p14="http://schemas.microsoft.com/office/powerpoint/2010/main" val="561354944"/>
       </p:ext>
     </p:extLst>
   </p:cSld>
@@ -5591,7 +5591,7 @@
           <p:cNvPr id="1" name="slide-title">
             <a:extLst xmlns:a="http://schemas.openxmlformats.org/drawingml/2006/main">
               <a:ext uri="{FF2B5EF4-FFF2-40B4-BE49-F238E27FC236}">
-                <a16:creationId xmlns:a16="http://schemas.microsoft.com/office/drawing/2014/main" id="{31026571-4229-4385-8018-4881D2DA1900}"/>
+                <a16:creationId xmlns:a16="http://schemas.microsoft.com/office/drawing/2014/main" id="{2644DCBA-5E77-4154-A492-5B1E2EEC3A94}"/>
               </a:ext>
             </a:extLst>
           </p:cNvPr>
@@ -5636,7 +5636,7 @@
           <p:cNvPr id="2" name="">
             <a:extLst xmlns:a="http://schemas.openxmlformats.org/drawingml/2006/main">
               <a:ext uri="{FF2B5EF4-FFF2-40B4-BE49-F238E27FC236}">
-                <a16:creationId xmlns:a16="http://schemas.microsoft.com/office/drawing/2014/main" id="{FA23FCDD-9D50-4871-80F0-756A9B1793CF}"/>
+                <a16:creationId xmlns:a16="http://schemas.microsoft.com/office/drawing/2014/main" id="{72F9B693-19B7-4FC0-A144-8BE0A2DB35EF}"/>
               </a:ext>
             </a:extLst>
           </p:cNvPr>
@@ -5669,7 +5669,7 @@
           <p:cNvPr id="3" name="text">
             <a:extLst xmlns:a="http://schemas.openxmlformats.org/drawingml/2006/main">
               <a:ext uri="{FF2B5EF4-FFF2-40B4-BE49-F238E27FC236}">
-                <a16:creationId xmlns:a16="http://schemas.microsoft.com/office/drawing/2014/main" id="{57C0487E-41C9-4023-94C8-D80AC41192FA}"/>
+                <a16:creationId xmlns:a16="http://schemas.microsoft.com/office/drawing/2014/main" id="{4DA93F08-33C5-4D35-94E0-CF5DACA3A912}"/>
               </a:ext>
             </a:extLst>
           </p:cNvPr>
@@ -5714,7 +5714,7 @@
           <p:cNvPr id="4" name="text">
             <a:extLst xmlns:a="http://schemas.openxmlformats.org/drawingml/2006/main">
               <a:ext uri="{FF2B5EF4-FFF2-40B4-BE49-F238E27FC236}">
-                <a16:creationId xmlns:a16="http://schemas.microsoft.com/office/drawing/2014/main" id="{35446D54-FD82-4792-8B50-3A7AF4F778AF}"/>
+                <a16:creationId xmlns:a16="http://schemas.microsoft.com/office/drawing/2014/main" id="{286A5236-FF4D-4B36-8ED3-95379F18AEF1}"/>
               </a:ext>
             </a:extLst>
           </p:cNvPr>
@@ -5759,7 +5759,7 @@
           <p:cNvPr id="5" name="text">
             <a:extLst xmlns:a="http://schemas.openxmlformats.org/drawingml/2006/main">
               <a:ext uri="{FF2B5EF4-FFF2-40B4-BE49-F238E27FC236}">
-                <a16:creationId xmlns:a16="http://schemas.microsoft.com/office/drawing/2014/main" id="{AA4B54E5-03C1-483E-90E4-CBC3E6F18E1F}"/>
+                <a16:creationId xmlns:a16="http://schemas.microsoft.com/office/drawing/2014/main" id="{7CC4C0A2-0620-4572-8BB1-872753E43F77}"/>
               </a:ext>
             </a:extLst>
           </p:cNvPr>
@@ -5804,7 +5804,7 @@
           <p:cNvPr id="6" name="text">
             <a:extLst xmlns:a="http://schemas.openxmlformats.org/drawingml/2006/main">
               <a:ext uri="{FF2B5EF4-FFF2-40B4-BE49-F238E27FC236}">
-                <a16:creationId xmlns:a16="http://schemas.microsoft.com/office/drawing/2014/main" id="{BBCB6800-EE0D-4B17-8CE7-90B9052A904C}"/>
+                <a16:creationId xmlns:a16="http://schemas.microsoft.com/office/drawing/2014/main" id="{CA0B70B0-19B4-4DE8-9DF2-4CB59B536BB4}"/>
               </a:ext>
             </a:extLst>
           </p:cNvPr>
@@ -5849,7 +5849,7 @@
           <p:cNvPr id="7" name="text">
             <a:extLst xmlns:a="http://schemas.openxmlformats.org/drawingml/2006/main">
               <a:ext uri="{FF2B5EF4-FFF2-40B4-BE49-F238E27FC236}">
-                <a16:creationId xmlns:a16="http://schemas.microsoft.com/office/drawing/2014/main" id="{55A8FEBE-8108-40DA-8926-F0C29689A514}"/>
+                <a16:creationId xmlns:a16="http://schemas.microsoft.com/office/drawing/2014/main" id="{0006ED13-D715-498E-965E-6EF473A47D5A}"/>
               </a:ext>
             </a:extLst>
           </p:cNvPr>
@@ -5894,7 +5894,7 @@
           <p:cNvPr id="8" name="text">
             <a:extLst xmlns:a="http://schemas.openxmlformats.org/drawingml/2006/main">
               <a:ext uri="{FF2B5EF4-FFF2-40B4-BE49-F238E27FC236}">
-                <a16:creationId xmlns:a16="http://schemas.microsoft.com/office/drawing/2014/main" id="{8103F726-04C5-4AA6-B2C5-1BFDFBB77A04}"/>
+                <a16:creationId xmlns:a16="http://schemas.microsoft.com/office/drawing/2014/main" id="{490ACA76-5A8F-4AA1-B44F-EBF19DB27B19}"/>
               </a:ext>
             </a:extLst>
           </p:cNvPr>
@@ -5939,7 +5939,7 @@
           <p:cNvPr id="9" name="text">
             <a:extLst xmlns:a="http://schemas.openxmlformats.org/drawingml/2006/main">
               <a:ext uri="{FF2B5EF4-FFF2-40B4-BE49-F238E27FC236}">
-                <a16:creationId xmlns:a16="http://schemas.microsoft.com/office/drawing/2014/main" id="{75FBB0E9-D6C9-4D4E-B4E5-001D6E1DF489}"/>
+                <a16:creationId xmlns:a16="http://schemas.microsoft.com/office/drawing/2014/main" id="{7D85BB14-B835-4B64-88FD-EF92938EFA7C}"/>
               </a:ext>
             </a:extLst>
           </p:cNvPr>
@@ -5984,7 +5984,7 @@
           <p:cNvPr id="10" name="text">
             <a:extLst xmlns:a="http://schemas.openxmlformats.org/drawingml/2006/main">
               <a:ext uri="{FF2B5EF4-FFF2-40B4-BE49-F238E27FC236}">
-                <a16:creationId xmlns:a16="http://schemas.microsoft.com/office/drawing/2014/main" id="{13B2E0CC-29B0-4B93-80F0-E3821897CE0B}"/>
+                <a16:creationId xmlns:a16="http://schemas.microsoft.com/office/drawing/2014/main" id="{B91B4D19-AD24-4AEC-919F-119420895391}"/>
               </a:ext>
             </a:extLst>
           </p:cNvPr>
@@ -6029,7 +6029,7 @@
           <p:cNvPr id="11" name="">
             <a:extLst xmlns:a="http://schemas.openxmlformats.org/drawingml/2006/main">
               <a:ext uri="{FF2B5EF4-FFF2-40B4-BE49-F238E27FC236}">
-                <a16:creationId xmlns:a16="http://schemas.microsoft.com/office/drawing/2014/main" id="{5239E297-91A3-4CAC-883C-425C9E799158}"/>
+                <a16:creationId xmlns:a16="http://schemas.microsoft.com/office/drawing/2014/main" id="{3B1D235D-A0DF-4321-A250-0ABE474F82F4}"/>
               </a:ext>
             </a:extLst>
           </p:cNvPr>
@@ -6062,7 +6062,7 @@
           <p:cNvPr id="12" name="text">
             <a:extLst xmlns:a="http://schemas.openxmlformats.org/drawingml/2006/main">
               <a:ext uri="{FF2B5EF4-FFF2-40B4-BE49-F238E27FC236}">
-                <a16:creationId xmlns:a16="http://schemas.microsoft.com/office/drawing/2014/main" id="{818D4777-A3BB-4B77-A208-ABAA1AB38454}"/>
+                <a16:creationId xmlns:a16="http://schemas.microsoft.com/office/drawing/2014/main" id="{0C820901-AD20-4847-AD1E-B9386E39D392}"/>
               </a:ext>
             </a:extLst>
           </p:cNvPr>
@@ -6107,7 +6107,7 @@
           <p:cNvPr id="13" name="footer">
             <a:extLst xmlns:a="http://schemas.openxmlformats.org/drawingml/2006/main">
               <a:ext uri="{FF2B5EF4-FFF2-40B4-BE49-F238E27FC236}">
-                <a16:creationId xmlns:a16="http://schemas.microsoft.com/office/drawing/2014/main" id="{38AD2F0D-4401-471C-862A-5AAA6D185547}"/>
+                <a16:creationId xmlns:a16="http://schemas.microsoft.com/office/drawing/2014/main" id="{7949385D-2C42-469F-B5E5-138AE976DEB3}"/>
               </a:ext>
             </a:extLst>
           </p:cNvPr>
@@ -6150,7 +6150,7 @@
     </p:spTree>
     <p:extLst>
       <p:ext uri="{BB962C8B-B14F-4D97-AF65-F5344CB8AC3E}">
-        <p14:creationId xmlns:p14="http://schemas.microsoft.com/office/powerpoint/2010/main" val="1458375025"/>
+        <p14:creationId xmlns:p14="http://schemas.microsoft.com/office/powerpoint/2010/main" val="592253067"/>
       </p:ext>
     </p:extLst>
   </p:cSld>

</xml_diff>